<commit_message>
chore(public): sanitize for public mirror [auto by push-public.sh]
</commit_message>
<xml_diff>
--- a/docs/CTDIPitchDeckv1.0.0.pptx
+++ b/docs/CTDIPitchDeckv1.0.0.pptx
@@ -2351,7 +2351,7 @@
                 <a:ea typeface="Calibri" pitchFamily="34" charset="-122"/>
                 <a:cs typeface="Calibri" pitchFamily="34" charset="-120"/>
               </a:rPr>
-              <a:t>CS Executive Services, LLC        github.com/CorporateTravelDC</a:t>
+              <a:t>[operator LLC], LLC        github.com/CorporateTravelDC</a:t>
             </a:r>
             <a:endParaRPr lang="en-US" sz="1100" dirty="0"/>
           </a:p>
@@ -7045,7 +7045,7 @@
                 <a:ea typeface="Calibri" pitchFamily="34" charset="-122"/>
                 <a:cs typeface="Calibri" pitchFamily="34" charset="-120"/>
               </a:rPr>
-              <a:t>coreywsheldon@pm.me</a:t>
+              <a:t>owner@example.com</a:t>
             </a:r>
             <a:endParaRPr lang="en-US" sz="1300" dirty="0"/>
           </a:p>
@@ -7211,7 +7211,7 @@
                 <a:ea typeface="Calibri" pitchFamily="34" charset="-122"/>
                 <a:cs typeface="Calibri" pitchFamily="34" charset="-120"/>
               </a:rPr>
-              <a:t>linkedin.com/in/coreysheldon</a:t>
+              <a:t>linkedin.com/in/operatorsheldon</a:t>
             </a:r>
             <a:endParaRPr lang="en-US" sz="1300" dirty="0"/>
           </a:p>
@@ -7333,7 +7333,7 @@
                 <a:ea typeface="Calibri" pitchFamily="34" charset="-122"/>
                 <a:cs typeface="Calibri" pitchFamily="34" charset="-120"/>
               </a:rPr>
-              <a:t>CTDI is developed and operated by CS Executive Services, LLC. All rights reserved.</a:t>
+              <a:t>CTDI is developed and operated by [operator LLC], LLC. All rights reserved.</a:t>
             </a:r>
             <a:endParaRPr lang="en-US" sz="1000" dirty="0"/>
           </a:p>

</xml_diff>